<commit_message>
added additional coordinate and variable definitions and information
</commit_message>
<xml_diff>
--- a/extras/images/coordinate_images.pptx
+++ b/extras/images/coordinate_images.pptx
@@ -3452,15 +3452,15 @@
                     </a:ext>
                   </a:extLst>
                 </a:blip>
-                <a:srcRect l="29790" t="21826" r="34281" b="21564"/>
+                <a:srcRect l="29790" t="31786" r="34281" b="21958"/>
                 <a:stretch>
                   <a:fillRect/>
                 </a:stretch>
               </p:blipFill>
               <p:spPr bwMode="auto">
                 <a:xfrm>
-                  <a:off x="3515976" y="1229192"/>
-                  <a:ext cx="1844587" cy="1757680"/>
+                  <a:off x="3515976" y="1538408"/>
+                  <a:ext cx="1844587" cy="1436205"/>
                 </a:xfrm>
                 <a:prstGeom prst="rect">
                   <a:avLst/>
@@ -6017,10 +6017,10 @@
         </p:nvGrpSpPr>
         <p:grpSpPr>
           <a:xfrm>
-            <a:off x="6328075" y="896230"/>
-            <a:ext cx="4170680" cy="4973320"/>
-            <a:chOff x="6328075" y="896230"/>
-            <a:chExt cx="4170680" cy="4973320"/>
+            <a:off x="6328074" y="896230"/>
+            <a:ext cx="4476565" cy="4973320"/>
+            <a:chOff x="6328074" y="896230"/>
+            <a:chExt cx="4476565" cy="4973320"/>
           </a:xfrm>
         </p:grpSpPr>
         <p:grpSp>
@@ -6037,10 +6037,10 @@
           </p:nvGrpSpPr>
           <p:grpSpPr>
             <a:xfrm>
-              <a:off x="6328075" y="896230"/>
-              <a:ext cx="4170680" cy="4973320"/>
-              <a:chOff x="6328075" y="896230"/>
-              <a:chExt cx="4170680" cy="4973320"/>
+              <a:off x="6328074" y="896230"/>
+              <a:ext cx="4476565" cy="4973320"/>
+              <a:chOff x="6328074" y="896230"/>
+              <a:chExt cx="4476565" cy="4973320"/>
             </a:xfrm>
           </p:grpSpPr>
           <p:sp>
@@ -6057,8 +6057,8 @@
             </p:nvSpPr>
             <p:spPr>
               <a:xfrm>
-                <a:off x="6328075" y="896230"/>
-                <a:ext cx="4170680" cy="4973320"/>
+                <a:off x="6328074" y="896230"/>
+                <a:ext cx="4476565" cy="4973320"/>
               </a:xfrm>
               <a:prstGeom prst="rect">
                 <a:avLst/>
@@ -6088,7 +6088,7 @@
               <a:lstStyle/>
               <a:p>
                 <a:pPr algn="ctr"/>
-                <a:endParaRPr lang="en-US"/>
+                <a:endParaRPr lang="en-US" dirty="0"/>
               </a:p>
             </p:txBody>
           </p:sp>
@@ -6134,7 +6134,7 @@
                     </a:ext>
                   </a:extLst>
                 </a:blip>
-                <a:srcRect l="14125" t="21826" r="49123" b="21564"/>
+                <a:srcRect l="14125" t="21826" r="49123" b="31208"/>
                 <a:stretch>
                   <a:fillRect/>
                 </a:stretch>
@@ -6142,7 +6142,7 @@
               <p:spPr bwMode="auto">
                 <a:xfrm>
                   <a:off x="7935704" y="1126293"/>
-                  <a:ext cx="1886849" cy="1757680"/>
+                  <a:ext cx="1886849" cy="1458264"/>
                 </a:xfrm>
                 <a:prstGeom prst="rect">
                   <a:avLst/>
@@ -9253,6 +9253,187 @@
           </p:sp>
         </mc:Fallback>
       </mc:AlternateContent>
+      <p:cxnSp>
+        <p:nvCxnSpPr>
+          <p:cNvPr id="176" name="Straight Arrow Connector 175">
+            <a:extLst>
+              <a:ext uri="{FF2B5EF4-FFF2-40B4-BE49-F238E27FC236}">
+                <a16:creationId xmlns:a16="http://schemas.microsoft.com/office/drawing/2014/main" id="{1C2B4816-81A8-2646-0898-B137118A7BDB}"/>
+              </a:ext>
+            </a:extLst>
+          </p:cNvPr>
+          <p:cNvCxnSpPr/>
+          <p:nvPr/>
+        </p:nvCxnSpPr>
+        <p:spPr>
+          <a:xfrm flipV="1">
+            <a:off x="9944282" y="1900981"/>
+            <a:ext cx="0" cy="314844"/>
+          </a:xfrm>
+          <a:prstGeom prst="straightConnector1">
+            <a:avLst/>
+          </a:prstGeom>
+          <a:ln w="38100">
+            <a:solidFill>
+              <a:schemeClr val="accent1"/>
+            </a:solidFill>
+            <a:tailEnd type="triangle"/>
+          </a:ln>
+        </p:spPr>
+        <p:style>
+          <a:lnRef idx="2">
+            <a:schemeClr val="accent1"/>
+          </a:lnRef>
+          <a:fillRef idx="0">
+            <a:schemeClr val="accent1"/>
+          </a:fillRef>
+          <a:effectRef idx="1">
+            <a:schemeClr val="accent1"/>
+          </a:effectRef>
+          <a:fontRef idx="minor">
+            <a:schemeClr val="tx1"/>
+          </a:fontRef>
+        </p:style>
+      </p:cxnSp>
+      <mc:AlternateContent xmlns:mc="http://schemas.openxmlformats.org/markup-compatibility/2006">
+        <mc:Choice xmlns:a14="http://schemas.microsoft.com/office/drawing/2010/main" Requires="a14">
+          <p:sp>
+            <p:nvSpPr>
+              <p:cNvPr id="177" name="TextBox 176">
+                <a:extLst>
+                  <a:ext uri="{FF2B5EF4-FFF2-40B4-BE49-F238E27FC236}">
+                    <a16:creationId xmlns:a16="http://schemas.microsoft.com/office/drawing/2014/main" id="{76D35460-8744-A60C-2631-2E88CA0AB897}"/>
+                  </a:ext>
+                </a:extLst>
+              </p:cNvPr>
+              <p:cNvSpPr txBox="1"/>
+              <p:nvPr/>
+            </p:nvSpPr>
+            <p:spPr>
+              <a:xfrm>
+                <a:off x="9976231" y="1788023"/>
+                <a:ext cx="603749" cy="557204"/>
+              </a:xfrm>
+              <a:prstGeom prst="rect">
+                <a:avLst/>
+              </a:prstGeom>
+              <a:noFill/>
+            </p:spPr>
+            <p:txBody>
+              <a:bodyPr wrap="square" rtlCol="0">
+                <a:spAutoFit/>
+              </a:bodyPr>
+              <a:lstStyle/>
+              <a:p>
+                <a14:m>
+                  <m:oMathPara xmlns:m="http://schemas.openxmlformats.org/officeDocument/2006/math">
+                    <m:oMathParaPr>
+                      <m:jc m:val="centerGroup"/>
+                    </m:oMathParaPr>
+                    <m:oMath xmlns:m="http://schemas.openxmlformats.org/officeDocument/2006/math">
+                      <m:r>
+                        <m:rPr>
+                          <m:sty m:val="p"/>
+                        </m:rPr>
+                        <a:rPr lang="en-US" sz="2800" b="0" i="0" smtClean="0">
+                          <a:solidFill>
+                            <a:schemeClr val="accent1"/>
+                          </a:solidFill>
+                          <a:latin typeface="Cambria Math" panose="02040503050406030204" pitchFamily="18" charset="0"/>
+                        </a:rPr>
+                        <m:t>Δ</m:t>
+                      </m:r>
+                      <m:sSub>
+                        <m:sSubPr>
+                          <m:ctrlPr>
+                            <a:rPr lang="en-US" sz="2800" b="0" i="1" smtClean="0">
+                              <a:solidFill>
+                                <a:schemeClr val="accent1"/>
+                              </a:solidFill>
+                              <a:latin typeface="Cambria Math" panose="02040503050406030204" pitchFamily="18" charset="0"/>
+                            </a:rPr>
+                          </m:ctrlPr>
+                        </m:sSubPr>
+                        <m:e>
+                          <m:r>
+                            <a:rPr lang="en-US" sz="2800" b="0" i="1" smtClean="0">
+                              <a:solidFill>
+                                <a:schemeClr val="accent1"/>
+                              </a:solidFill>
+                              <a:latin typeface="Cambria Math" panose="02040503050406030204" pitchFamily="18" charset="0"/>
+                            </a:rPr>
+                            <m:t>𝑑</m:t>
+                          </m:r>
+                        </m:e>
+                        <m:sub>
+                          <m:r>
+                            <a:rPr lang="en-US" sz="2800" b="0" i="1" smtClean="0">
+                              <a:solidFill>
+                                <a:schemeClr val="accent1"/>
+                              </a:solidFill>
+                              <a:latin typeface="Cambria Math" panose="02040503050406030204" pitchFamily="18" charset="0"/>
+                            </a:rPr>
+                            <m:t>𝑦</m:t>
+                          </m:r>
+                        </m:sub>
+                      </m:sSub>
+                    </m:oMath>
+                  </m:oMathPara>
+                </a14:m>
+                <a:endParaRPr lang="en-US" sz="2800" dirty="0">
+                  <a:solidFill>
+                    <a:schemeClr val="accent1"/>
+                  </a:solidFill>
+                </a:endParaRPr>
+              </a:p>
+            </p:txBody>
+          </p:sp>
+        </mc:Choice>
+        <mc:Fallback>
+          <p:sp>
+            <p:nvSpPr>
+              <p:cNvPr id="177" name="TextBox 176">
+                <a:extLst>
+                  <a:ext uri="{FF2B5EF4-FFF2-40B4-BE49-F238E27FC236}">
+                    <a16:creationId xmlns:a16="http://schemas.microsoft.com/office/drawing/2014/main" id="{76D35460-8744-A60C-2631-2E88CA0AB897}"/>
+                  </a:ext>
+                </a:extLst>
+              </p:cNvPr>
+              <p:cNvSpPr txBox="1">
+                <a:spLocks noRot="1" noChangeAspect="1" noMove="1" noResize="1" noEditPoints="1" noAdjustHandles="1" noChangeArrowheads="1" noChangeShapeType="1" noTextEdit="1"/>
+              </p:cNvSpPr>
+              <p:nvPr/>
+            </p:nvSpPr>
+            <p:spPr>
+              <a:xfrm>
+                <a:off x="9976231" y="1788023"/>
+                <a:ext cx="603749" cy="557204"/>
+              </a:xfrm>
+              <a:prstGeom prst="rect">
+                <a:avLst/>
+              </a:prstGeom>
+              <a:blipFill>
+                <a:blip r:embed="rId27"/>
+                <a:stretch>
+                  <a:fillRect r="-11111"/>
+                </a:stretch>
+              </a:blipFill>
+            </p:spPr>
+            <p:txBody>
+              <a:bodyPr/>
+              <a:lstStyle/>
+              <a:p>
+                <a:r>
+                  <a:rPr lang="en-US">
+                    <a:noFill/>
+                  </a:rPr>
+                  <a:t> </a:t>
+                </a:r>
+              </a:p>
+            </p:txBody>
+          </p:sp>
+        </mc:Fallback>
+      </mc:AlternateContent>
     </p:spTree>
     <p:extLst>
       <p:ext uri="{BB962C8B-B14F-4D97-AF65-F5344CB8AC3E}">

</xml_diff>

<commit_message>
fixing leftover merge conflict text in the files
</commit_message>
<xml_diff>
--- a/extras/images/coordinate_images.pptx
+++ b/extras/images/coordinate_images.pptx
@@ -104,6 +104,11 @@
       </a:defRPr>
     </a:lvl9pPr>
   </p:defaultTextStyle>
+  <p:extLst>
+    <p:ext uri="{EFAFB233-063F-42B5-8137-9DF3F51BA10A}">
+      <p15:sldGuideLst xmlns:p15="http://schemas.microsoft.com/office/powerpoint/2012/main"/>
+    </p:ext>
+  </p:extLst>
 </p:presentation>
 </file>
 
@@ -254,7 +259,7 @@
           <a:p>
             <a:fld id="{558BFAFD-BD34-4CE5-A649-EF0E21030FB1}" type="datetimeFigureOut">
               <a:rPr lang="en-US" smtClean="0"/>
-              <a:t>7/7/2026</a:t>
+              <a:t>7/13/2026</a:t>
             </a:fld>
             <a:endParaRPr lang="en-US"/>
           </a:p>
@@ -452,7 +457,7 @@
           <a:p>
             <a:fld id="{558BFAFD-BD34-4CE5-A649-EF0E21030FB1}" type="datetimeFigureOut">
               <a:rPr lang="en-US" smtClean="0"/>
-              <a:t>7/7/2026</a:t>
+              <a:t>7/13/2026</a:t>
             </a:fld>
             <a:endParaRPr lang="en-US"/>
           </a:p>
@@ -660,7 +665,7 @@
           <a:p>
             <a:fld id="{558BFAFD-BD34-4CE5-A649-EF0E21030FB1}" type="datetimeFigureOut">
               <a:rPr lang="en-US" smtClean="0"/>
-              <a:t>7/7/2026</a:t>
+              <a:t>7/13/2026</a:t>
             </a:fld>
             <a:endParaRPr lang="en-US"/>
           </a:p>
@@ -858,7 +863,7 @@
           <a:p>
             <a:fld id="{558BFAFD-BD34-4CE5-A649-EF0E21030FB1}" type="datetimeFigureOut">
               <a:rPr lang="en-US" smtClean="0"/>
-              <a:t>7/7/2026</a:t>
+              <a:t>7/13/2026</a:t>
             </a:fld>
             <a:endParaRPr lang="en-US"/>
           </a:p>
@@ -1133,7 +1138,7 @@
           <a:p>
             <a:fld id="{558BFAFD-BD34-4CE5-A649-EF0E21030FB1}" type="datetimeFigureOut">
               <a:rPr lang="en-US" smtClean="0"/>
-              <a:t>7/7/2026</a:t>
+              <a:t>7/13/2026</a:t>
             </a:fld>
             <a:endParaRPr lang="en-US"/>
           </a:p>
@@ -1398,7 +1403,7 @@
           <a:p>
             <a:fld id="{558BFAFD-BD34-4CE5-A649-EF0E21030FB1}" type="datetimeFigureOut">
               <a:rPr lang="en-US" smtClean="0"/>
-              <a:t>7/7/2026</a:t>
+              <a:t>7/13/2026</a:t>
             </a:fld>
             <a:endParaRPr lang="en-US"/>
           </a:p>
@@ -1810,7 +1815,7 @@
           <a:p>
             <a:fld id="{558BFAFD-BD34-4CE5-A649-EF0E21030FB1}" type="datetimeFigureOut">
               <a:rPr lang="en-US" smtClean="0"/>
-              <a:t>7/7/2026</a:t>
+              <a:t>7/13/2026</a:t>
             </a:fld>
             <a:endParaRPr lang="en-US"/>
           </a:p>
@@ -1951,7 +1956,7 @@
           <a:p>
             <a:fld id="{558BFAFD-BD34-4CE5-A649-EF0E21030FB1}" type="datetimeFigureOut">
               <a:rPr lang="en-US" smtClean="0"/>
-              <a:t>7/7/2026</a:t>
+              <a:t>7/13/2026</a:t>
             </a:fld>
             <a:endParaRPr lang="en-US"/>
           </a:p>
@@ -2064,7 +2069,7 @@
           <a:p>
             <a:fld id="{558BFAFD-BD34-4CE5-A649-EF0E21030FB1}" type="datetimeFigureOut">
               <a:rPr lang="en-US" smtClean="0"/>
-              <a:t>7/7/2026</a:t>
+              <a:t>7/13/2026</a:t>
             </a:fld>
             <a:endParaRPr lang="en-US"/>
           </a:p>
@@ -2375,7 +2380,7 @@
           <a:p>
             <a:fld id="{558BFAFD-BD34-4CE5-A649-EF0E21030FB1}" type="datetimeFigureOut">
               <a:rPr lang="en-US" smtClean="0"/>
-              <a:t>7/7/2026</a:t>
+              <a:t>7/13/2026</a:t>
             </a:fld>
             <a:endParaRPr lang="en-US"/>
           </a:p>
@@ -2663,7 +2668,7 @@
           <a:p>
             <a:fld id="{558BFAFD-BD34-4CE5-A649-EF0E21030FB1}" type="datetimeFigureOut">
               <a:rPr lang="en-US" smtClean="0"/>
-              <a:t>7/7/2026</a:t>
+              <a:t>7/13/2026</a:t>
             </a:fld>
             <a:endParaRPr lang="en-US"/>
           </a:p>
@@ -2904,7 +2909,7 @@
           <a:p>
             <a:fld id="{558BFAFD-BD34-4CE5-A649-EF0E21030FB1}" type="datetimeFigureOut">
               <a:rPr lang="en-US" smtClean="0"/>
-              <a:t>7/7/2026</a:t>
+              <a:t>7/13/2026</a:t>
             </a:fld>
             <a:endParaRPr lang="en-US"/>
           </a:p>
@@ -4064,8 +4069,8 @@
                 </a:p>
               </p:txBody>
             </p:sp>
-            <mc:AlternateContent xmlns:mc="http://schemas.openxmlformats.org/markup-compatibility/2006">
-              <mc:Choice xmlns:a14="http://schemas.microsoft.com/office/drawing/2010/main" Requires="a14">
+            <mc:AlternateContent xmlns:mc="http://schemas.openxmlformats.org/markup-compatibility/2006" xmlns:a14="http://schemas.microsoft.com/office/drawing/2010/main">
+              <mc:Choice Requires="a14">
                 <p:sp>
                   <p:nvSpPr>
                     <p:cNvPr id="26" name="TextBox 25">
@@ -4094,6 +4099,7 @@
                     </a:bodyPr>
                     <a:lstStyle/>
                     <a:p>
+                      <a:pPr/>
                       <a14:m>
                         <m:oMathPara xmlns:m="http://schemas.openxmlformats.org/officeDocument/2006/math">
                           <m:oMathParaPr>
@@ -4121,7 +4127,7 @@
                   </p:txBody>
                 </p:sp>
               </mc:Choice>
-              <mc:Fallback>
+              <mc:Fallback xmlns="">
                 <p:sp>
                   <p:nvSpPr>
                     <p:cNvPr id="26" name="TextBox 25">
@@ -4343,8 +4349,8 @@
                 </a:fontRef>
               </p:style>
             </p:cxnSp>
-            <mc:AlternateContent xmlns:mc="http://schemas.openxmlformats.org/markup-compatibility/2006">
-              <mc:Choice xmlns:a14="http://schemas.microsoft.com/office/drawing/2010/main" Requires="a14">
+            <mc:AlternateContent xmlns:mc="http://schemas.openxmlformats.org/markup-compatibility/2006" xmlns:a14="http://schemas.microsoft.com/office/drawing/2010/main">
+              <mc:Choice Requires="a14">
                 <p:sp>
                   <p:nvSpPr>
                     <p:cNvPr id="50" name="TextBox 49">
@@ -4373,6 +4379,7 @@
                     </a:bodyPr>
                     <a:lstStyle/>
                     <a:p>
+                      <a:pPr/>
                       <a14:m>
                         <m:oMathPara xmlns:m="http://schemas.openxmlformats.org/officeDocument/2006/math">
                           <m:oMathParaPr>
@@ -4437,7 +4444,7 @@
                   </p:txBody>
                 </p:sp>
               </mc:Choice>
-              <mc:Fallback>
+              <mc:Fallback xmlns="">
                 <p:sp>
                   <p:nvSpPr>
                     <p:cNvPr id="50" name="TextBox 49">
@@ -4482,8 +4489,8 @@
                 </p:sp>
               </mc:Fallback>
             </mc:AlternateContent>
-            <mc:AlternateContent xmlns:mc="http://schemas.openxmlformats.org/markup-compatibility/2006">
-              <mc:Choice xmlns:a14="http://schemas.microsoft.com/office/drawing/2010/main" Requires="a14">
+            <mc:AlternateContent xmlns:mc="http://schemas.openxmlformats.org/markup-compatibility/2006" xmlns:a14="http://schemas.microsoft.com/office/drawing/2010/main">
+              <mc:Choice Requires="a14">
                 <p:sp>
                   <p:nvSpPr>
                     <p:cNvPr id="51" name="TextBox 50">
@@ -4512,6 +4519,7 @@
                     </a:bodyPr>
                     <a:lstStyle/>
                     <a:p>
+                      <a:pPr/>
                       <a14:m>
                         <m:oMathPara xmlns:m="http://schemas.openxmlformats.org/officeDocument/2006/math">
                           <m:oMathParaPr>
@@ -4576,7 +4584,7 @@
                   </p:txBody>
                 </p:sp>
               </mc:Choice>
-              <mc:Fallback>
+              <mc:Fallback xmlns="">
                 <p:sp>
                   <p:nvSpPr>
                     <p:cNvPr id="51" name="TextBox 50">
@@ -4621,8 +4629,8 @@
                 </p:sp>
               </mc:Fallback>
             </mc:AlternateContent>
-            <mc:AlternateContent xmlns:mc="http://schemas.openxmlformats.org/markup-compatibility/2006">
-              <mc:Choice xmlns:a14="http://schemas.microsoft.com/office/drawing/2010/main" Requires="a14">
+            <mc:AlternateContent xmlns:mc="http://schemas.openxmlformats.org/markup-compatibility/2006" xmlns:a14="http://schemas.microsoft.com/office/drawing/2010/main">
+              <mc:Choice Requires="a14">
                 <p:sp>
                   <p:nvSpPr>
                     <p:cNvPr id="52" name="TextBox 51">
@@ -4651,6 +4659,7 @@
                     </a:bodyPr>
                     <a:lstStyle/>
                     <a:p>
+                      <a:pPr/>
                       <a14:m>
                         <m:oMathPara xmlns:m="http://schemas.openxmlformats.org/officeDocument/2006/math">
                           <m:oMathParaPr>
@@ -4715,7 +4724,7 @@
                   </p:txBody>
                 </p:sp>
               </mc:Choice>
-              <mc:Fallback>
+              <mc:Fallback xmlns="">
                 <p:sp>
                   <p:nvSpPr>
                     <p:cNvPr id="52" name="TextBox 51">
@@ -4893,8 +4902,8 @@
                 </a:fontRef>
               </p:style>
             </p:cxnSp>
-            <mc:AlternateContent xmlns:mc="http://schemas.openxmlformats.org/markup-compatibility/2006">
-              <mc:Choice xmlns:a14="http://schemas.microsoft.com/office/drawing/2010/main" Requires="a14">
+            <mc:AlternateContent xmlns:mc="http://schemas.openxmlformats.org/markup-compatibility/2006" xmlns:a14="http://schemas.microsoft.com/office/drawing/2010/main">
+              <mc:Choice Requires="a14">
                 <p:sp>
                   <p:nvSpPr>
                     <p:cNvPr id="61" name="TextBox 60">
@@ -4923,6 +4932,7 @@
                     </a:bodyPr>
                     <a:lstStyle/>
                     <a:p>
+                      <a:pPr/>
                       <a14:m>
                         <m:oMathPara xmlns:m="http://schemas.openxmlformats.org/officeDocument/2006/math">
                           <m:oMathParaPr>
@@ -5042,7 +5052,7 @@
                   </p:txBody>
                 </p:sp>
               </mc:Choice>
-              <mc:Fallback>
+              <mc:Fallback xmlns="">
                 <p:sp>
                   <p:nvSpPr>
                     <p:cNvPr id="61" name="TextBox 60">
@@ -5087,8 +5097,8 @@
                 </p:sp>
               </mc:Fallback>
             </mc:AlternateContent>
-            <mc:AlternateContent xmlns:mc="http://schemas.openxmlformats.org/markup-compatibility/2006">
-              <mc:Choice xmlns:a14="http://schemas.microsoft.com/office/drawing/2010/main" Requires="a14">
+            <mc:AlternateContent xmlns:mc="http://schemas.openxmlformats.org/markup-compatibility/2006" xmlns:a14="http://schemas.microsoft.com/office/drawing/2010/main">
+              <mc:Choice Requires="a14">
                 <p:sp>
                   <p:nvSpPr>
                     <p:cNvPr id="62" name="TextBox 61">
@@ -5117,6 +5127,7 @@
                     </a:bodyPr>
                     <a:lstStyle/>
                     <a:p>
+                      <a:pPr/>
                       <a14:m>
                         <m:oMathPara xmlns:m="http://schemas.openxmlformats.org/officeDocument/2006/math">
                           <m:oMathParaPr>
@@ -5236,7 +5247,7 @@
                   </p:txBody>
                 </p:sp>
               </mc:Choice>
-              <mc:Fallback>
+              <mc:Fallback xmlns="">
                 <p:sp>
                   <p:nvSpPr>
                     <p:cNvPr id="62" name="TextBox 61">
@@ -5281,8 +5292,8 @@
                 </p:sp>
               </mc:Fallback>
             </mc:AlternateContent>
-            <mc:AlternateContent xmlns:mc="http://schemas.openxmlformats.org/markup-compatibility/2006">
-              <mc:Choice xmlns:a14="http://schemas.microsoft.com/office/drawing/2010/main" Requires="a14">
+            <mc:AlternateContent xmlns:mc="http://schemas.openxmlformats.org/markup-compatibility/2006" xmlns:a14="http://schemas.microsoft.com/office/drawing/2010/main">
+              <mc:Choice Requires="a14">
                 <p:sp>
                   <p:nvSpPr>
                     <p:cNvPr id="65" name="TextBox 64">
@@ -5311,6 +5322,7 @@
                     </a:bodyPr>
                     <a:lstStyle/>
                     <a:p>
+                      <a:pPr/>
                       <a14:m>
                         <m:oMathPara xmlns:m="http://schemas.openxmlformats.org/officeDocument/2006/math">
                           <m:oMathParaPr>
@@ -5430,7 +5442,7 @@
                   </p:txBody>
                 </p:sp>
               </mc:Choice>
-              <mc:Fallback>
+              <mc:Fallback xmlns="">
                 <p:sp>
                   <p:nvSpPr>
                     <p:cNvPr id="65" name="TextBox 64">
@@ -5637,8 +5649,8 @@
                 </a:p>
               </p:txBody>
             </p:sp>
-            <mc:AlternateContent xmlns:mc="http://schemas.openxmlformats.org/markup-compatibility/2006">
-              <mc:Choice xmlns:a14="http://schemas.microsoft.com/office/drawing/2010/main" Requires="a14">
+            <mc:AlternateContent xmlns:mc="http://schemas.openxmlformats.org/markup-compatibility/2006" xmlns:a14="http://schemas.microsoft.com/office/drawing/2010/main">
+              <mc:Choice Requires="a14">
                 <p:sp>
                   <p:nvSpPr>
                     <p:cNvPr id="70" name="TextBox 69">
@@ -5667,6 +5679,7 @@
                     </a:bodyPr>
                     <a:lstStyle/>
                     <a:p>
+                      <a:pPr/>
                       <a14:m>
                         <m:oMathPara xmlns:m="http://schemas.openxmlformats.org/officeDocument/2006/math">
                           <m:oMathParaPr>
@@ -5700,7 +5713,7 @@
                   </p:txBody>
                 </p:sp>
               </mc:Choice>
-              <mc:Fallback>
+              <mc:Fallback xmlns="">
                 <p:sp>
                   <p:nvSpPr>
                     <p:cNvPr id="70" name="TextBox 69">
@@ -5745,8 +5758,8 @@
                 </p:sp>
               </mc:Fallback>
             </mc:AlternateContent>
-            <mc:AlternateContent xmlns:mc="http://schemas.openxmlformats.org/markup-compatibility/2006">
-              <mc:Choice xmlns:a14="http://schemas.microsoft.com/office/drawing/2010/main" Requires="a14">
+            <mc:AlternateContent xmlns:mc="http://schemas.openxmlformats.org/markup-compatibility/2006" xmlns:a14="http://schemas.microsoft.com/office/drawing/2010/main">
+              <mc:Choice Requires="a14">
                 <p:sp>
                   <p:nvSpPr>
                     <p:cNvPr id="71" name="TextBox 70">
@@ -5775,6 +5788,7 @@
                     </a:bodyPr>
                     <a:lstStyle/>
                     <a:p>
+                      <a:pPr/>
                       <a14:m>
                         <m:oMathPara xmlns:m="http://schemas.openxmlformats.org/officeDocument/2006/math">
                           <m:oMathParaPr>
@@ -5808,7 +5822,7 @@
                   </p:txBody>
                 </p:sp>
               </mc:Choice>
-              <mc:Fallback>
+              <mc:Fallback xmlns="">
                 <p:sp>
                   <p:nvSpPr>
                     <p:cNvPr id="71" name="TextBox 70">
@@ -5853,8 +5867,8 @@
                 </p:sp>
               </mc:Fallback>
             </mc:AlternateContent>
-            <mc:AlternateContent xmlns:mc="http://schemas.openxmlformats.org/markup-compatibility/2006">
-              <mc:Choice xmlns:a14="http://schemas.microsoft.com/office/drawing/2010/main" Requires="a14">
+            <mc:AlternateContent xmlns:mc="http://schemas.openxmlformats.org/markup-compatibility/2006" xmlns:a14="http://schemas.microsoft.com/office/drawing/2010/main">
+              <mc:Choice Requires="a14">
                 <p:sp>
                   <p:nvSpPr>
                     <p:cNvPr id="72" name="TextBox 71">
@@ -5883,6 +5897,7 @@
                     </a:bodyPr>
                     <a:lstStyle/>
                     <a:p>
+                      <a:pPr/>
                       <a14:m>
                         <m:oMathPara xmlns:m="http://schemas.openxmlformats.org/officeDocument/2006/math">
                           <m:oMathParaPr>
@@ -5916,7 +5931,7 @@
                   </p:txBody>
                 </p:sp>
               </mc:Choice>
-              <mc:Fallback>
+              <mc:Fallback xmlns="">
                 <p:sp>
                   <p:nvSpPr>
                     <p:cNvPr id="72" name="TextBox 71">
@@ -6047,8 +6062,8 @@
           </a:fontRef>
         </p:style>
       </p:cxnSp>
-      <mc:AlternateContent xmlns:mc="http://schemas.openxmlformats.org/markup-compatibility/2006">
-        <mc:Choice xmlns:a14="http://schemas.microsoft.com/office/drawing/2010/main" Requires="a14">
+      <mc:AlternateContent xmlns:mc="http://schemas.openxmlformats.org/markup-compatibility/2006" xmlns:a14="http://schemas.microsoft.com/office/drawing/2010/main">
+        <mc:Choice Requires="a14">
           <p:sp>
             <p:nvSpPr>
               <p:cNvPr id="169" name="TextBox 168">
@@ -6077,6 +6092,7 @@
               </a:bodyPr>
               <a:lstStyle/>
               <a:p>
+                <a:pPr/>
                 <a14:m>
                   <m:oMathPara xmlns:m="http://schemas.openxmlformats.org/officeDocument/2006/math">
                     <m:oMathParaPr>
@@ -6104,7 +6120,7 @@
             </p:txBody>
           </p:sp>
         </mc:Choice>
-        <mc:Fallback>
+        <mc:Fallback xmlns="">
           <p:sp>
             <p:nvSpPr>
               <p:cNvPr id="169" name="TextBox 168">
@@ -6912,8 +6928,8 @@
                   </a:p>
                 </p:txBody>
               </p:sp>
-              <mc:AlternateContent xmlns:mc="http://schemas.openxmlformats.org/markup-compatibility/2006">
-                <mc:Choice xmlns:a14="http://schemas.microsoft.com/office/drawing/2010/main" Requires="a14">
+              <mc:AlternateContent xmlns:mc="http://schemas.openxmlformats.org/markup-compatibility/2006" xmlns:a14="http://schemas.microsoft.com/office/drawing/2010/main">
+                <mc:Choice Requires="a14">
                   <p:sp>
                     <p:nvSpPr>
                       <p:cNvPr id="84" name="TextBox 83">
@@ -6942,6 +6958,7 @@
                       </a:bodyPr>
                       <a:lstStyle/>
                       <a:p>
+                        <a:pPr/>
                         <a14:m>
                           <m:oMathPara xmlns:m="http://schemas.openxmlformats.org/officeDocument/2006/math">
                             <m:oMathParaPr>
@@ -7006,7 +7023,7 @@
                     </p:txBody>
                   </p:sp>
                 </mc:Choice>
-                <mc:Fallback>
+                <mc:Fallback xmlns="">
                   <p:sp>
                     <p:nvSpPr>
                       <p:cNvPr id="84" name="TextBox 83">
@@ -7361,8 +7378,8 @@
                   </a:fontRef>
                 </p:style>
               </p:cxnSp>
-              <mc:AlternateContent xmlns:mc="http://schemas.openxmlformats.org/markup-compatibility/2006">
-                <mc:Choice xmlns:a14="http://schemas.microsoft.com/office/drawing/2010/main" Requires="a14">
+              <mc:AlternateContent xmlns:mc="http://schemas.openxmlformats.org/markup-compatibility/2006" xmlns:a14="http://schemas.microsoft.com/office/drawing/2010/main">
+                <mc:Choice Requires="a14">
                   <p:sp>
                     <p:nvSpPr>
                       <p:cNvPr id="95" name="TextBox 94">
@@ -7391,6 +7408,7 @@
                       </a:bodyPr>
                       <a:lstStyle/>
                       <a:p>
+                        <a:pPr/>
                         <a14:m>
                           <m:oMathPara xmlns:m="http://schemas.openxmlformats.org/officeDocument/2006/math">
                             <m:oMathParaPr>
@@ -7455,7 +7473,7 @@
                     </p:txBody>
                   </p:sp>
                 </mc:Choice>
-                <mc:Fallback>
+                <mc:Fallback xmlns="">
                   <p:sp>
                     <p:nvSpPr>
                       <p:cNvPr id="95" name="TextBox 94">
@@ -7500,8 +7518,8 @@
                   </p:sp>
                 </mc:Fallback>
               </mc:AlternateContent>
-              <mc:AlternateContent xmlns:mc="http://schemas.openxmlformats.org/markup-compatibility/2006">
-                <mc:Choice xmlns:a14="http://schemas.microsoft.com/office/drawing/2010/main" Requires="a14">
+              <mc:AlternateContent xmlns:mc="http://schemas.openxmlformats.org/markup-compatibility/2006" xmlns:a14="http://schemas.microsoft.com/office/drawing/2010/main">
+                <mc:Choice Requires="a14">
                   <p:sp>
                     <p:nvSpPr>
                       <p:cNvPr id="96" name="TextBox 95">
@@ -7530,6 +7548,7 @@
                       </a:bodyPr>
                       <a:lstStyle/>
                       <a:p>
+                        <a:pPr/>
                         <a14:m>
                           <m:oMathPara xmlns:m="http://schemas.openxmlformats.org/officeDocument/2006/math">
                             <m:oMathParaPr>
@@ -7594,7 +7613,7 @@
                     </p:txBody>
                   </p:sp>
                 </mc:Choice>
-                <mc:Fallback>
+                <mc:Fallback xmlns="">
                   <p:sp>
                     <p:nvSpPr>
                       <p:cNvPr id="96" name="TextBox 95">
@@ -7639,8 +7658,8 @@
                   </p:sp>
                 </mc:Fallback>
               </mc:AlternateContent>
-              <mc:AlternateContent xmlns:mc="http://schemas.openxmlformats.org/markup-compatibility/2006">
-                <mc:Choice xmlns:a14="http://schemas.microsoft.com/office/drawing/2010/main" Requires="a14">
+              <mc:AlternateContent xmlns:mc="http://schemas.openxmlformats.org/markup-compatibility/2006" xmlns:a14="http://schemas.microsoft.com/office/drawing/2010/main">
+                <mc:Choice Requires="a14">
                   <p:sp>
                     <p:nvSpPr>
                       <p:cNvPr id="97" name="TextBox 96">
@@ -7669,6 +7688,7 @@
                       </a:bodyPr>
                       <a:lstStyle/>
                       <a:p>
+                        <a:pPr/>
                         <a14:m>
                           <m:oMathPara xmlns:m="http://schemas.openxmlformats.org/officeDocument/2006/math">
                             <m:oMathParaPr>
@@ -7733,7 +7753,7 @@
                     </p:txBody>
                   </p:sp>
                 </mc:Choice>
-                <mc:Fallback>
+                <mc:Fallback xmlns="">
                   <p:sp>
                     <p:nvSpPr>
                       <p:cNvPr id="97" name="TextBox 96">
@@ -7940,8 +7960,8 @@
                   </a:p>
                 </p:txBody>
               </p:sp>
-              <mc:AlternateContent xmlns:mc="http://schemas.openxmlformats.org/markup-compatibility/2006">
-                <mc:Choice xmlns:a14="http://schemas.microsoft.com/office/drawing/2010/main" Requires="a14">
+              <mc:AlternateContent xmlns:mc="http://schemas.openxmlformats.org/markup-compatibility/2006" xmlns:a14="http://schemas.microsoft.com/office/drawing/2010/main">
+                <mc:Choice Requires="a14">
                   <p:sp>
                     <p:nvSpPr>
                       <p:cNvPr id="101" name="TextBox 100">
@@ -7970,6 +7990,7 @@
                       </a:bodyPr>
                       <a:lstStyle/>
                       <a:p>
+                        <a:pPr/>
                         <a14:m>
                           <m:oMathPara xmlns:m="http://schemas.openxmlformats.org/officeDocument/2006/math">
                             <m:oMathParaPr>
@@ -8003,7 +8024,7 @@
                     </p:txBody>
                   </p:sp>
                 </mc:Choice>
-                <mc:Fallback>
+                <mc:Fallback xmlns="">
                   <p:sp>
                     <p:nvSpPr>
                       <p:cNvPr id="101" name="TextBox 100">
@@ -8048,8 +8069,8 @@
                   </p:sp>
                 </mc:Fallback>
               </mc:AlternateContent>
-              <mc:AlternateContent xmlns:mc="http://schemas.openxmlformats.org/markup-compatibility/2006">
-                <mc:Choice xmlns:a14="http://schemas.microsoft.com/office/drawing/2010/main" Requires="a14">
+              <mc:AlternateContent xmlns:mc="http://schemas.openxmlformats.org/markup-compatibility/2006" xmlns:a14="http://schemas.microsoft.com/office/drawing/2010/main">
+                <mc:Choice Requires="a14">
                   <p:sp>
                     <p:nvSpPr>
                       <p:cNvPr id="102" name="TextBox 101">
@@ -8078,6 +8099,7 @@
                       </a:bodyPr>
                       <a:lstStyle/>
                       <a:p>
+                        <a:pPr/>
                         <a14:m>
                           <m:oMathPara xmlns:m="http://schemas.openxmlformats.org/officeDocument/2006/math">
                             <m:oMathParaPr>
@@ -8111,7 +8133,7 @@
                     </p:txBody>
                   </p:sp>
                 </mc:Choice>
-                <mc:Fallback>
+                <mc:Fallback xmlns="">
                   <p:sp>
                     <p:nvSpPr>
                       <p:cNvPr id="102" name="TextBox 101">
@@ -8156,8 +8178,8 @@
                   </p:sp>
                 </mc:Fallback>
               </mc:AlternateContent>
-              <mc:AlternateContent xmlns:mc="http://schemas.openxmlformats.org/markup-compatibility/2006">
-                <mc:Choice xmlns:a14="http://schemas.microsoft.com/office/drawing/2010/main" Requires="a14">
+              <mc:AlternateContent xmlns:mc="http://schemas.openxmlformats.org/markup-compatibility/2006" xmlns:a14="http://schemas.microsoft.com/office/drawing/2010/main">
+                <mc:Choice Requires="a14">
                   <p:sp>
                     <p:nvSpPr>
                       <p:cNvPr id="103" name="TextBox 102">
@@ -8186,6 +8208,7 @@
                       </a:bodyPr>
                       <a:lstStyle/>
                       <a:p>
+                        <a:pPr/>
                         <a14:m>
                           <m:oMathPara xmlns:m="http://schemas.openxmlformats.org/officeDocument/2006/math">
                             <m:oMathParaPr>
@@ -8219,7 +8242,7 @@
                     </p:txBody>
                   </p:sp>
                 </mc:Choice>
-                <mc:Fallback>
+                <mc:Fallback xmlns="">
                   <p:sp>
                     <p:nvSpPr>
                       <p:cNvPr id="103" name="TextBox 102">
@@ -8397,8 +8420,8 @@
                   </a:fontRef>
                 </p:style>
               </p:cxnSp>
-              <mc:AlternateContent xmlns:mc="http://schemas.openxmlformats.org/markup-compatibility/2006">
-                <mc:Choice xmlns:a14="http://schemas.microsoft.com/office/drawing/2010/main" Requires="a14">
+              <mc:AlternateContent xmlns:mc="http://schemas.openxmlformats.org/markup-compatibility/2006" xmlns:a14="http://schemas.microsoft.com/office/drawing/2010/main">
+                <mc:Choice Requires="a14">
                   <p:sp>
                     <p:nvSpPr>
                       <p:cNvPr id="110" name="TextBox 109">
@@ -8427,6 +8450,7 @@
                       </a:bodyPr>
                       <a:lstStyle/>
                       <a:p>
+                        <a:pPr/>
                         <a14:m>
                           <m:oMathPara xmlns:m="http://schemas.openxmlformats.org/officeDocument/2006/math">
                             <m:oMathParaPr>
@@ -8491,7 +8515,7 @@
                     </p:txBody>
                   </p:sp>
                 </mc:Choice>
-                <mc:Fallback>
+                <mc:Fallback xmlns="">
                   <p:sp>
                     <p:nvSpPr>
                       <p:cNvPr id="110" name="TextBox 109">
@@ -8536,8 +8560,8 @@
                   </p:sp>
                 </mc:Fallback>
               </mc:AlternateContent>
-              <mc:AlternateContent xmlns:mc="http://schemas.openxmlformats.org/markup-compatibility/2006">
-                <mc:Choice xmlns:a14="http://schemas.microsoft.com/office/drawing/2010/main" Requires="a14">
+              <mc:AlternateContent xmlns:mc="http://schemas.openxmlformats.org/markup-compatibility/2006" xmlns:a14="http://schemas.microsoft.com/office/drawing/2010/main">
+                <mc:Choice Requires="a14">
                   <p:sp>
                     <p:nvSpPr>
                       <p:cNvPr id="111" name="TextBox 110">
@@ -8566,6 +8590,7 @@
                       </a:bodyPr>
                       <a:lstStyle/>
                       <a:p>
+                        <a:pPr/>
                         <a14:m>
                           <m:oMathPara xmlns:m="http://schemas.openxmlformats.org/officeDocument/2006/math">
                             <m:oMathParaPr>
@@ -8630,7 +8655,7 @@
                     </p:txBody>
                   </p:sp>
                 </mc:Choice>
-                <mc:Fallback>
+                <mc:Fallback xmlns="">
                   <p:sp>
                     <p:nvSpPr>
                       <p:cNvPr id="111" name="TextBox 110">
@@ -8675,8 +8700,8 @@
                   </p:sp>
                 </mc:Fallback>
               </mc:AlternateContent>
-              <mc:AlternateContent xmlns:mc="http://schemas.openxmlformats.org/markup-compatibility/2006">
-                <mc:Choice xmlns:a14="http://schemas.microsoft.com/office/drawing/2010/main" Requires="a14">
+              <mc:AlternateContent xmlns:mc="http://schemas.openxmlformats.org/markup-compatibility/2006" xmlns:a14="http://schemas.microsoft.com/office/drawing/2010/main">
+                <mc:Choice Requires="a14">
                   <p:sp>
                     <p:nvSpPr>
                       <p:cNvPr id="112" name="TextBox 111">
@@ -8705,6 +8730,7 @@
                       </a:bodyPr>
                       <a:lstStyle/>
                       <a:p>
+                        <a:pPr/>
                         <a14:m>
                           <m:oMathPara xmlns:m="http://schemas.openxmlformats.org/officeDocument/2006/math">
                             <m:oMathParaPr>
@@ -8769,7 +8795,7 @@
                     </p:txBody>
                   </p:sp>
                 </mc:Choice>
-                <mc:Fallback>
+                <mc:Fallback xmlns="">
                   <p:sp>
                     <p:nvSpPr>
                       <p:cNvPr id="112" name="TextBox 111">
@@ -8856,8 +8882,8 @@
             </p:txBody>
           </p:sp>
         </p:grpSp>
-        <mc:AlternateContent xmlns:mc="http://schemas.openxmlformats.org/markup-compatibility/2006">
-          <mc:Choice xmlns:a14="http://schemas.microsoft.com/office/drawing/2010/main" Requires="a14">
+        <mc:AlternateContent xmlns:mc="http://schemas.openxmlformats.org/markup-compatibility/2006" xmlns:a14="http://schemas.microsoft.com/office/drawing/2010/main">
+          <mc:Choice Requires="a14">
             <p:sp>
               <p:nvSpPr>
                 <p:cNvPr id="170" name="TextBox 169">
@@ -8886,6 +8912,7 @@
                 </a:bodyPr>
                 <a:lstStyle/>
                 <a:p>
+                  <a:pPr/>
                   <a14:m>
                     <m:oMathPara xmlns:m="http://schemas.openxmlformats.org/officeDocument/2006/math">
                       <m:oMathParaPr>
@@ -8950,7 +8977,7 @@
               </p:txBody>
             </p:sp>
           </mc:Choice>
-          <mc:Fallback>
+          <mc:Fallback xmlns="">
             <p:sp>
               <p:nvSpPr>
                 <p:cNvPr id="170" name="TextBox 169">
@@ -8995,8 +9022,8 @@
             </p:sp>
           </mc:Fallback>
         </mc:AlternateContent>
-        <mc:AlternateContent xmlns:mc="http://schemas.openxmlformats.org/markup-compatibility/2006">
-          <mc:Choice xmlns:a14="http://schemas.microsoft.com/office/drawing/2010/main" Requires="a14">
+        <mc:AlternateContent xmlns:mc="http://schemas.openxmlformats.org/markup-compatibility/2006" xmlns:a14="http://schemas.microsoft.com/office/drawing/2010/main">
+          <mc:Choice Requires="a14">
             <p:sp>
               <p:nvSpPr>
                 <p:cNvPr id="171" name="TextBox 170">
@@ -9025,6 +9052,7 @@
                 </a:bodyPr>
                 <a:lstStyle/>
                 <a:p>
+                  <a:pPr/>
                   <a14:m>
                     <m:oMathPara xmlns:m="http://schemas.openxmlformats.org/officeDocument/2006/math">
                       <m:oMathParaPr>
@@ -9089,7 +9117,7 @@
               </p:txBody>
             </p:sp>
           </mc:Choice>
-          <mc:Fallback>
+          <mc:Fallback xmlns="">
             <p:sp>
               <p:nvSpPr>
                 <p:cNvPr id="171" name="TextBox 170">
@@ -9134,8 +9162,8 @@
             </p:sp>
           </mc:Fallback>
         </mc:AlternateContent>
-        <mc:AlternateContent xmlns:mc="http://schemas.openxmlformats.org/markup-compatibility/2006">
-          <mc:Choice xmlns:a14="http://schemas.microsoft.com/office/drawing/2010/main" Requires="a14">
+        <mc:AlternateContent xmlns:mc="http://schemas.openxmlformats.org/markup-compatibility/2006" xmlns:a14="http://schemas.microsoft.com/office/drawing/2010/main">
+          <mc:Choice Requires="a14">
             <p:sp>
               <p:nvSpPr>
                 <p:cNvPr id="172" name="TextBox 171">
@@ -9164,6 +9192,7 @@
                 </a:bodyPr>
                 <a:lstStyle/>
                 <a:p>
+                  <a:pPr/>
                   <a14:m>
                     <m:oMathPara xmlns:m="http://schemas.openxmlformats.org/officeDocument/2006/math">
                       <m:oMathParaPr>
@@ -9228,7 +9257,7 @@
               </p:txBody>
             </p:sp>
           </mc:Choice>
-          <mc:Fallback>
+          <mc:Fallback xmlns="">
             <p:sp>
               <p:nvSpPr>
                 <p:cNvPr id="172" name="TextBox 171">
@@ -9315,8 +9344,8 @@
             </a:fontRef>
           </p:style>
         </p:cxnSp>
-        <mc:AlternateContent xmlns:mc="http://schemas.openxmlformats.org/markup-compatibility/2006">
-          <mc:Choice xmlns:a14="http://schemas.microsoft.com/office/drawing/2010/main" Requires="a14">
+        <mc:AlternateContent xmlns:mc="http://schemas.openxmlformats.org/markup-compatibility/2006" xmlns:a14="http://schemas.microsoft.com/office/drawing/2010/main">
+          <mc:Choice Requires="a14">
             <p:sp>
               <p:nvSpPr>
                 <p:cNvPr id="177" name="TextBox 176">
@@ -9345,6 +9374,7 @@
                 </a:bodyPr>
                 <a:lstStyle/>
                 <a:p>
+                  <a:pPr/>
                   <a14:m>
                     <m:oMathPara xmlns:m="http://schemas.openxmlformats.org/officeDocument/2006/math">
                       <m:oMathParaPr>
@@ -9409,7 +9439,7 @@
               </p:txBody>
             </p:sp>
           </mc:Choice>
-          <mc:Fallback>
+          <mc:Fallback xmlns="">
             <p:sp>
               <p:nvSpPr>
                 <p:cNvPr id="177" name="TextBox 176">

</xml_diff>